<commit_message>
Rebuild outreach PPT and PDF with live product screens
Replace text-heavy slides with visual compositions using real
BarathX phone/desktop screens — title, product trio, Square/Arenas,
and a screen-led one-pager PDF.

Co-authored-by: sharathtestits-code <sharathtestits-code@users.noreply.github.com>
</commit_message>
<xml_diff>
--- a/brand/gtm/outreach/emails-2026-08-18/BarathX-Creator-Collab-Brief.pptx
+++ b/brand/gtm/outreach/emails-2026-08-18/BarathX-Creator-Collab-Brief.pptx
@@ -12,7 +12,7 @@
     <p:sldId id="260" r:id="rId11"/>
     <p:sldId id="261" r:id="rId12"/>
   </p:sldIdLst>
-  <p:sldSz cx="9144000" cy="6858000" type="screen4x3"/>
+  <p:sldSz cx="12191695" cy="6858000" type="screen4x3"/>
   <p:notesSz cx="6858000" cy="9144000"/>
   <p:defaultTextStyle>
     <a:defPPr>
@@ -3086,14 +3086,6 @@
 <file path=ppt/slides/slide1.xml><?xml version="1.0" encoding="utf-8"?>
 <p:sld xmlns:a="http://schemas.openxmlformats.org/drawingml/2006/main" xmlns:p="http://schemas.openxmlformats.org/presentationml/2006/main" xmlns:r="http://schemas.openxmlformats.org/officeDocument/2006/relationships">
   <p:cSld>
-    <p:bg>
-      <p:bgPr>
-        <a:solidFill>
-          <a:srgbClr val="0B1F3A"/>
-        </a:solidFill>
-        <a:effectLst/>
-      </p:bgPr>
-    </p:bg>
     <p:spTree>
       <p:nvGrpSpPr>
         <p:cNvPr id="1" name=""/>
@@ -3101,106 +3093,30 @@
         <p:nvPr/>
       </p:nvGrpSpPr>
       <p:grpSpPr/>
-      <p:sp>
-        <p:nvSpPr>
-          <p:cNvPr id="2" name="TextBox 1"/>
-          <p:cNvSpPr txBox="1"/>
+      <p:pic>
+        <p:nvPicPr>
+          <p:cNvPr id="2" name="Picture 1" descr="01-title.png"/>
+          <p:cNvPicPr>
+            <a:picLocks noChangeAspect="1"/>
+          </p:cNvPicPr>
           <p:nvPr/>
-        </p:nvSpPr>
+        </p:nvPicPr>
+        <p:blipFill>
+          <a:blip r:embed="rId2"/>
+          <a:stretch>
+            <a:fillRect/>
+          </a:stretch>
+        </p:blipFill>
         <p:spPr>
           <a:xfrm>
-            <a:off x="640080" y="1920240"/>
-            <a:ext cx="7863840" cy="2926080"/>
+            <a:off x="0" y="0"/>
+            <a:ext cx="12191695" cy="6858000"/>
           </a:xfrm>
           <a:prstGeom prst="rect">
             <a:avLst/>
           </a:prstGeom>
-          <a:noFill/>
         </p:spPr>
-        <p:txBody>
-          <a:bodyPr wrap="square">
-            <a:spAutoFit/>
-          </a:bodyPr>
-          <a:lstStyle/>
-          <a:p>
-            <a:r>
-              <a:rPr sz="4400" b="1">
-                <a:solidFill>
-                  <a:srgbClr val="FFFFFF"/>
-                </a:solidFill>
-                <a:latin typeface="Calibri"/>
-              </a:rPr>
-              <a:t>BarathX</a:t>
-            </a:r>
-          </a:p>
-          <a:p>
-            <a:pPr>
-              <a:spcBef>
-                <a:spcPts val="1400"/>
-              </a:spcBef>
-            </a:pPr>
-            <a:r>
-              <a:rPr sz="2000" b="0">
-                <a:solidFill>
-                  <a:srgbClr val="D8DEE6"/>
-                </a:solidFill>
-                <a:latin typeface="Calibri"/>
-              </a:rPr>
-              <a:t>India’s public square — creator collab brief</a:t>
-            </a:r>
-          </a:p>
-          <a:p>
-            <a:pPr>
-              <a:spcBef>
-                <a:spcPts val="1800"/>
-              </a:spcBef>
-            </a:pPr>
-            <a:r>
-              <a:rPr sz="1400" b="0">
-                <a:solidFill>
-                  <a:srgbClr val="E8B88A"/>
-                </a:solidFill>
-                <a:latin typeface="Calibri"/>
-              </a:rPr>
-              <a:t>Built by Indians · for Indians · owned by Indians</a:t>
-            </a:r>
-          </a:p>
-        </p:txBody>
-      </p:sp>
-      <p:sp>
-        <p:nvSpPr>
-          <p:cNvPr id="3" name="TextBox 2"/>
-          <p:cNvSpPr txBox="1"/>
-          <p:nvPr/>
-        </p:nvSpPr>
-        <p:spPr>
-          <a:xfrm>
-            <a:off x="640080" y="6309360"/>
-            <a:ext cx="7863840" cy="320040"/>
-          </a:xfrm>
-          <a:prstGeom prst="rect">
-            <a:avLst/>
-          </a:prstGeom>
-          <a:noFill/>
-        </p:spPr>
-        <p:txBody>
-          <a:bodyPr wrap="none">
-            <a:spAutoFit/>
-          </a:bodyPr>
-          <a:lstStyle/>
-          <a:p>
-            <a:r>
-              <a:rPr sz="1200" b="0">
-                <a:solidFill>
-                  <a:srgbClr val="A8B4C4"/>
-                </a:solidFill>
-                <a:latin typeface="Calibri"/>
-              </a:rPr>
-              <a:t>barathx.com  ·  @getbarathx</a:t>
-            </a:r>
-          </a:p>
-        </p:txBody>
-      </p:sp>
+      </p:pic>
     </p:spTree>
   </p:cSld>
   <p:clrMapOvr>
@@ -3212,14 +3128,6 @@
 <file path=ppt/slides/slide2.xml><?xml version="1.0" encoding="utf-8"?>
 <p:sld xmlns:a="http://schemas.openxmlformats.org/drawingml/2006/main" xmlns:p="http://schemas.openxmlformats.org/presentationml/2006/main" xmlns:r="http://schemas.openxmlformats.org/officeDocument/2006/relationships">
   <p:cSld>
-    <p:bg>
-      <p:bgPr>
-        <a:solidFill>
-          <a:srgbClr val="F7F4EF"/>
-        </a:solidFill>
-        <a:effectLst/>
-      </p:bgPr>
-    </p:bg>
     <p:spTree>
       <p:nvGrpSpPr>
         <p:cNvPr id="1" name=""/>
@@ -3227,145 +3135,30 @@
         <p:nvPr/>
       </p:nvGrpSpPr>
       <p:grpSpPr/>
-      <p:sp>
-        <p:nvSpPr>
-          <p:cNvPr id="2" name="TextBox 1"/>
-          <p:cNvSpPr txBox="1"/>
+      <p:pic>
+        <p:nvPicPr>
+          <p:cNvPr id="2" name="Picture 1" descr="02-problem.png"/>
+          <p:cNvPicPr>
+            <a:picLocks noChangeAspect="1"/>
+          </p:cNvPicPr>
           <p:nvPr/>
-        </p:nvSpPr>
+        </p:nvPicPr>
+        <p:blipFill>
+          <a:blip r:embed="rId2"/>
+          <a:stretch>
+            <a:fillRect/>
+          </a:stretch>
+        </p:blipFill>
         <p:spPr>
           <a:xfrm>
-            <a:off x="640080" y="777240"/>
-            <a:ext cx="7863840" cy="1371600"/>
+            <a:off x="0" y="0"/>
+            <a:ext cx="12191695" cy="6858000"/>
           </a:xfrm>
           <a:prstGeom prst="rect">
             <a:avLst/>
           </a:prstGeom>
-          <a:noFill/>
         </p:spPr>
-        <p:txBody>
-          <a:bodyPr wrap="square">
-            <a:spAutoFit/>
-          </a:bodyPr>
-          <a:lstStyle/>
-          <a:p>
-            <a:r>
-              <a:rPr sz="3200" b="1">
-                <a:solidFill>
-                  <a:srgbClr val="0B1F3A"/>
-                </a:solidFill>
-                <a:latin typeface="Calibri"/>
-              </a:rPr>
-              <a:t>The problem</a:t>
-            </a:r>
-          </a:p>
-        </p:txBody>
-      </p:sp>
-      <p:sp>
-        <p:nvSpPr>
-          <p:cNvPr id="3" name="TextBox 2"/>
-          <p:cNvSpPr txBox="1"/>
-          <p:nvPr/>
-        </p:nvSpPr>
-        <p:spPr>
-          <a:xfrm>
-            <a:off x="640080" y="2194560"/>
-            <a:ext cx="7863840" cy="3657600"/>
-          </a:xfrm>
-          <a:prstGeom prst="rect">
-            <a:avLst/>
-          </a:prstGeom>
-          <a:noFill/>
-        </p:spPr>
-        <p:txBody>
-          <a:bodyPr wrap="square">
-            <a:spAutoFit/>
-          </a:bodyPr>
-          <a:lstStyle/>
-          <a:p>
-            <a:pPr>
-              <a:spcAft>
-                <a:spcPts val="1200"/>
-              </a:spcAft>
-            </a:pPr>
-            <a:r>
-              <a:rPr sz="1800" b="0">
-                <a:solidFill>
-                  <a:srgbClr val="1A1A1A"/>
-                </a:solidFill>
-                <a:latin typeface="Calibri"/>
-              </a:rPr>
-              <a:t>Hot takes die in WhatsApp.</a:t>
-            </a:r>
-          </a:p>
-          <a:p>
-            <a:pPr>
-              <a:spcAft>
-                <a:spcPts val="1200"/>
-              </a:spcAft>
-            </a:pPr>
-            <a:r>
-              <a:rPr sz="1800" b="0">
-                <a:solidFill>
-                  <a:srgbClr val="1A1A1A"/>
-                </a:solidFill>
-                <a:latin typeface="Calibri"/>
-              </a:rPr>
-              <a:t>Reels want your thumb — not your opinion.</a:t>
-            </a:r>
-          </a:p>
-          <a:p>
-            <a:pPr>
-              <a:spcAft>
-                <a:spcPts val="1200"/>
-              </a:spcAft>
-            </a:pPr>
-            <a:r>
-              <a:rPr sz="1800" b="0">
-                <a:solidFill>
-                  <a:srgbClr val="1A1A1A"/>
-                </a:solidFill>
-                <a:latin typeface="Calibri"/>
-              </a:rPr>
-              <a:t>India needs a place to pick a side and argue it live.</a:t>
-            </a:r>
-          </a:p>
-        </p:txBody>
-      </p:sp>
-      <p:sp>
-        <p:nvSpPr>
-          <p:cNvPr id="4" name="TextBox 3"/>
-          <p:cNvSpPr txBox="1"/>
-          <p:nvPr/>
-        </p:nvSpPr>
-        <p:spPr>
-          <a:xfrm>
-            <a:off x="640080" y="6309360"/>
-            <a:ext cx="7863840" cy="320040"/>
-          </a:xfrm>
-          <a:prstGeom prst="rect">
-            <a:avLst/>
-          </a:prstGeom>
-          <a:noFill/>
-        </p:spPr>
-        <p:txBody>
-          <a:bodyPr wrap="none">
-            <a:spAutoFit/>
-          </a:bodyPr>
-          <a:lstStyle/>
-          <a:p>
-            <a:r>
-              <a:rPr sz="1200" b="0">
-                <a:solidFill>
-                  <a:srgbClr val="4A5563"/>
-                </a:solidFill>
-                <a:latin typeface="Calibri"/>
-              </a:rPr>
-              <a:t>barathx.com  ·  @getbarathx</a:t>
-            </a:r>
-          </a:p>
-        </p:txBody>
-      </p:sp>
+      </p:pic>
     </p:spTree>
   </p:cSld>
   <p:clrMapOvr>
@@ -3377,14 +3170,6 @@
 <file path=ppt/slides/slide3.xml><?xml version="1.0" encoding="utf-8"?>
 <p:sld xmlns:a="http://schemas.openxmlformats.org/drawingml/2006/main" xmlns:p="http://schemas.openxmlformats.org/presentationml/2006/main" xmlns:r="http://schemas.openxmlformats.org/officeDocument/2006/relationships">
   <p:cSld>
-    <p:bg>
-      <p:bgPr>
-        <a:solidFill>
-          <a:srgbClr val="F7F4EF"/>
-        </a:solidFill>
-        <a:effectLst/>
-      </p:bgPr>
-    </p:bg>
     <p:spTree>
       <p:nvGrpSpPr>
         <p:cNvPr id="1" name=""/>
@@ -3392,161 +3177,30 @@
         <p:nvPr/>
       </p:nvGrpSpPr>
       <p:grpSpPr/>
-      <p:sp>
-        <p:nvSpPr>
-          <p:cNvPr id="2" name="TextBox 1"/>
-          <p:cNvSpPr txBox="1"/>
+      <p:pic>
+        <p:nvPicPr>
+          <p:cNvPr id="2" name="Picture 1" descr="03-product.png"/>
+          <p:cNvPicPr>
+            <a:picLocks noChangeAspect="1"/>
+          </p:cNvPicPr>
           <p:nvPr/>
-        </p:nvSpPr>
+        </p:nvPicPr>
+        <p:blipFill>
+          <a:blip r:embed="rId2"/>
+          <a:stretch>
+            <a:fillRect/>
+          </a:stretch>
+        </p:blipFill>
         <p:spPr>
           <a:xfrm>
-            <a:off x="640080" y="777240"/>
-            <a:ext cx="7863840" cy="1371600"/>
+            <a:off x="0" y="0"/>
+            <a:ext cx="12191695" cy="6858000"/>
           </a:xfrm>
           <a:prstGeom prst="rect">
             <a:avLst/>
           </a:prstGeom>
-          <a:noFill/>
         </p:spPr>
-        <p:txBody>
-          <a:bodyPr wrap="square">
-            <a:spAutoFit/>
-          </a:bodyPr>
-          <a:lstStyle/>
-          <a:p>
-            <a:r>
-              <a:rPr sz="3200" b="1">
-                <a:solidFill>
-                  <a:srgbClr val="0B1F3A"/>
-                </a:solidFill>
-                <a:latin typeface="Calibri"/>
-              </a:rPr>
-              <a:t>What BarathX is</a:t>
-            </a:r>
-          </a:p>
-        </p:txBody>
-      </p:sp>
-      <p:sp>
-        <p:nvSpPr>
-          <p:cNvPr id="3" name="TextBox 2"/>
-          <p:cNvSpPr txBox="1"/>
-          <p:nvPr/>
-        </p:nvSpPr>
-        <p:spPr>
-          <a:xfrm>
-            <a:off x="640080" y="2194560"/>
-            <a:ext cx="7863840" cy="3657600"/>
-          </a:xfrm>
-          <a:prstGeom prst="rect">
-            <a:avLst/>
-          </a:prstGeom>
-          <a:noFill/>
-        </p:spPr>
-        <p:txBody>
-          <a:bodyPr wrap="square">
-            <a:spAutoFit/>
-          </a:bodyPr>
-          <a:lstStyle/>
-          <a:p>
-            <a:pPr>
-              <a:spcAft>
-                <a:spcPts val="1200"/>
-              </a:spcAft>
-            </a:pPr>
-            <a:r>
-              <a:rPr sz="1800" b="0">
-                <a:solidFill>
-                  <a:srgbClr val="1A1A1A"/>
-                </a:solidFill>
-                <a:latin typeface="Calibri"/>
-              </a:rPr>
-              <a:t>India’s public square — Square · Arenas · Live</a:t>
-            </a:r>
-          </a:p>
-          <a:p>
-            <a:pPr>
-              <a:spcAft>
-                <a:spcPts val="1200"/>
-              </a:spcAft>
-            </a:pPr>
-            <a:r>
-              <a:rPr sz="1800" b="0">
-                <a:solidFill>
-                  <a:srgbClr val="1A1A1A"/>
-                </a:solidFill>
-                <a:latin typeface="Calibri"/>
-              </a:rPr>
-              <a:t>Drop a take → pick a side → real replies</a:t>
-            </a:r>
-          </a:p>
-          <a:p>
-            <a:pPr>
-              <a:spcAft>
-                <a:spcPts val="1200"/>
-              </a:spcAft>
-            </a:pPr>
-            <a:r>
-              <a:rPr sz="1800" b="0">
-                <a:solidFill>
-                  <a:srgbClr val="1A1A1A"/>
-                </a:solidFill>
-                <a:latin typeface="Calibri"/>
-              </a:rPr>
-              <a:t>Human takes only. No AI slop.</a:t>
-            </a:r>
-          </a:p>
-          <a:p>
-            <a:pPr>
-              <a:spcAft>
-                <a:spcPts val="1200"/>
-              </a:spcAft>
-            </a:pPr>
-            <a:r>
-              <a:rPr sz="1800" b="0">
-                <a:solidFill>
-                  <a:srgbClr val="1A1A1A"/>
-                </a:solidFill>
-                <a:latin typeface="Calibri"/>
-              </a:rPr>
-              <a:t>Built by Indians, for Indians, owned by Indians</a:t>
-            </a:r>
-          </a:p>
-        </p:txBody>
-      </p:sp>
-      <p:sp>
-        <p:nvSpPr>
-          <p:cNvPr id="4" name="TextBox 3"/>
-          <p:cNvSpPr txBox="1"/>
-          <p:nvPr/>
-        </p:nvSpPr>
-        <p:spPr>
-          <a:xfrm>
-            <a:off x="640080" y="6309360"/>
-            <a:ext cx="7863840" cy="320040"/>
-          </a:xfrm>
-          <a:prstGeom prst="rect">
-            <a:avLst/>
-          </a:prstGeom>
-          <a:noFill/>
-        </p:spPr>
-        <p:txBody>
-          <a:bodyPr wrap="none">
-            <a:spAutoFit/>
-          </a:bodyPr>
-          <a:lstStyle/>
-          <a:p>
-            <a:r>
-              <a:rPr sz="1200" b="0">
-                <a:solidFill>
-                  <a:srgbClr val="4A5563"/>
-                </a:solidFill>
-                <a:latin typeface="Calibri"/>
-              </a:rPr>
-              <a:t>barathx.com  ·  @getbarathx</a:t>
-            </a:r>
-          </a:p>
-        </p:txBody>
-      </p:sp>
+      </p:pic>
     </p:spTree>
   </p:cSld>
   <p:clrMapOvr>
@@ -3558,14 +3212,6 @@
 <file path=ppt/slides/slide4.xml><?xml version="1.0" encoding="utf-8"?>
 <p:sld xmlns:a="http://schemas.openxmlformats.org/drawingml/2006/main" xmlns:p="http://schemas.openxmlformats.org/presentationml/2006/main" xmlns:r="http://schemas.openxmlformats.org/officeDocument/2006/relationships">
   <p:cSld>
-    <p:bg>
-      <p:bgPr>
-        <a:solidFill>
-          <a:srgbClr val="F7F4EF"/>
-        </a:solidFill>
-        <a:effectLst/>
-      </p:bgPr>
-    </p:bg>
     <p:spTree>
       <p:nvGrpSpPr>
         <p:cNvPr id="1" name=""/>
@@ -3573,145 +3219,30 @@
         <p:nvPr/>
       </p:nvGrpSpPr>
       <p:grpSpPr/>
-      <p:sp>
-        <p:nvSpPr>
-          <p:cNvPr id="2" name="TextBox 1"/>
-          <p:cNvSpPr txBox="1"/>
+      <p:pic>
+        <p:nvPicPr>
+          <p:cNvPr id="2" name="Picture 1" descr="04-live.png"/>
+          <p:cNvPicPr>
+            <a:picLocks noChangeAspect="1"/>
+          </p:cNvPicPr>
           <p:nvPr/>
-        </p:nvSpPr>
+        </p:nvPicPr>
+        <p:blipFill>
+          <a:blip r:embed="rId2"/>
+          <a:stretch>
+            <a:fillRect/>
+          </a:stretch>
+        </p:blipFill>
         <p:spPr>
           <a:xfrm>
-            <a:off x="640080" y="777240"/>
-            <a:ext cx="7863840" cy="1371600"/>
+            <a:off x="0" y="0"/>
+            <a:ext cx="12191695" cy="6858000"/>
           </a:xfrm>
           <a:prstGeom prst="rect">
             <a:avLst/>
           </a:prstGeom>
-          <a:noFill/>
         </p:spPr>
-        <p:txBody>
-          <a:bodyPr wrap="square">
-            <a:spAutoFit/>
-          </a:bodyPr>
-          <a:lstStyle/>
-          <a:p>
-            <a:r>
-              <a:rPr sz="3200" b="1">
-                <a:solidFill>
-                  <a:srgbClr val="0B1F3A"/>
-                </a:solidFill>
-                <a:latin typeface="Calibri"/>
-              </a:rPr>
-              <a:t>Why creators</a:t>
-            </a:r>
-          </a:p>
-        </p:txBody>
-      </p:sp>
-      <p:sp>
-        <p:nvSpPr>
-          <p:cNvPr id="3" name="TextBox 2"/>
-          <p:cNvSpPr txBox="1"/>
-          <p:nvPr/>
-        </p:nvSpPr>
-        <p:spPr>
-          <a:xfrm>
-            <a:off x="640080" y="2194560"/>
-            <a:ext cx="7863840" cy="3657600"/>
-          </a:xfrm>
-          <a:prstGeom prst="rect">
-            <a:avLst/>
-          </a:prstGeom>
-          <a:noFill/>
-        </p:spPr>
-        <p:txBody>
-          <a:bodyPr wrap="square">
-            <a:spAutoFit/>
-          </a:bodyPr>
-          <a:lstStyle/>
-          <a:p>
-            <a:pPr>
-              <a:spcAft>
-                <a:spcPts val="1200"/>
-              </a:spcAft>
-            </a:pPr>
-            <a:r>
-              <a:rPr sz="1800" b="0">
-                <a:solidFill>
-                  <a:srgbClr val="1A1A1A"/>
-                </a:solidFill>
-                <a:latin typeface="Calibri"/>
-              </a:rPr>
-              <a:t>Gen Z trusts niche creators more than ads.</a:t>
-            </a:r>
-          </a:p>
-          <a:p>
-            <a:pPr>
-              <a:spcAft>
-                <a:spcPts val="1200"/>
-              </a:spcAft>
-            </a:pPr>
-            <a:r>
-              <a:rPr sz="1800" b="0">
-                <a:solidFill>
-                  <a:srgbClr val="1A1A1A"/>
-                </a:solidFill>
-                <a:latin typeface="Calibri"/>
-              </a:rPr>
-              <a:t>Your audience already argues in comments.</a:t>
-            </a:r>
-          </a:p>
-          <a:p>
-            <a:pPr>
-              <a:spcAft>
-                <a:spcPts val="1200"/>
-              </a:spcAft>
-            </a:pPr>
-            <a:r>
-              <a:rPr sz="1800" b="0">
-                <a:solidFill>
-                  <a:srgbClr val="1A1A1A"/>
-                </a:solidFill>
-                <a:latin typeface="Calibri"/>
-              </a:rPr>
-              <a:t>We give them a square — you keep creative control.</a:t>
-            </a:r>
-          </a:p>
-        </p:txBody>
-      </p:sp>
-      <p:sp>
-        <p:nvSpPr>
-          <p:cNvPr id="4" name="TextBox 3"/>
-          <p:cNvSpPr txBox="1"/>
-          <p:nvPr/>
-        </p:nvSpPr>
-        <p:spPr>
-          <a:xfrm>
-            <a:off x="640080" y="6309360"/>
-            <a:ext cx="7863840" cy="320040"/>
-          </a:xfrm>
-          <a:prstGeom prst="rect">
-            <a:avLst/>
-          </a:prstGeom>
-          <a:noFill/>
-        </p:spPr>
-        <p:txBody>
-          <a:bodyPr wrap="none">
-            <a:spAutoFit/>
-          </a:bodyPr>
-          <a:lstStyle/>
-          <a:p>
-            <a:r>
-              <a:rPr sz="1200" b="0">
-                <a:solidFill>
-                  <a:srgbClr val="4A5563"/>
-                </a:solidFill>
-                <a:latin typeface="Calibri"/>
-              </a:rPr>
-              <a:t>barathx.com  ·  @getbarathx</a:t>
-            </a:r>
-          </a:p>
-        </p:txBody>
-      </p:sp>
+      </p:pic>
     </p:spTree>
   </p:cSld>
   <p:clrMapOvr>
@@ -3723,14 +3254,6 @@
 <file path=ppt/slides/slide5.xml><?xml version="1.0" encoding="utf-8"?>
 <p:sld xmlns:a="http://schemas.openxmlformats.org/drawingml/2006/main" xmlns:p="http://schemas.openxmlformats.org/presentationml/2006/main" xmlns:r="http://schemas.openxmlformats.org/officeDocument/2006/relationships">
   <p:cSld>
-    <p:bg>
-      <p:bgPr>
-        <a:solidFill>
-          <a:srgbClr val="F7F4EF"/>
-        </a:solidFill>
-        <a:effectLst/>
-      </p:bgPr>
-    </p:bg>
     <p:spTree>
       <p:nvGrpSpPr>
         <p:cNvPr id="1" name=""/>
@@ -3738,161 +3261,30 @@
         <p:nvPr/>
       </p:nvGrpSpPr>
       <p:grpSpPr/>
-      <p:sp>
-        <p:nvSpPr>
-          <p:cNvPr id="2" name="TextBox 1"/>
-          <p:cNvSpPr txBox="1"/>
+      <p:pic>
+        <p:nvPicPr>
+          <p:cNvPr id="2" name="Picture 1" descr="05-india.png"/>
+          <p:cNvPicPr>
+            <a:picLocks noChangeAspect="1"/>
+          </p:cNvPicPr>
           <p:nvPr/>
-        </p:nvSpPr>
+        </p:nvPicPr>
+        <p:blipFill>
+          <a:blip r:embed="rId2"/>
+          <a:stretch>
+            <a:fillRect/>
+          </a:stretch>
+        </p:blipFill>
         <p:spPr>
           <a:xfrm>
-            <a:off x="640080" y="777240"/>
-            <a:ext cx="7863840" cy="1371600"/>
+            <a:off x="0" y="0"/>
+            <a:ext cx="12191695" cy="6858000"/>
           </a:xfrm>
           <a:prstGeom prst="rect">
             <a:avLst/>
           </a:prstGeom>
-          <a:noFill/>
         </p:spPr>
-        <p:txBody>
-          <a:bodyPr wrap="square">
-            <a:spAutoFit/>
-          </a:bodyPr>
-          <a:lstStyle/>
-          <a:p>
-            <a:r>
-              <a:rPr sz="3200" b="1">
-                <a:solidFill>
-                  <a:srgbClr val="0B1F3A"/>
-                </a:solidFill>
-                <a:latin typeface="Calibri"/>
-              </a:rPr>
-              <a:t>The ask</a:t>
-            </a:r>
-          </a:p>
-        </p:txBody>
-      </p:sp>
-      <p:sp>
-        <p:nvSpPr>
-          <p:cNvPr id="3" name="TextBox 2"/>
-          <p:cNvSpPr txBox="1"/>
-          <p:nvPr/>
-        </p:nvSpPr>
-        <p:spPr>
-          <a:xfrm>
-            <a:off x="640080" y="2194560"/>
-            <a:ext cx="7863840" cy="3657600"/>
-          </a:xfrm>
-          <a:prstGeom prst="rect">
-            <a:avLst/>
-          </a:prstGeom>
-          <a:noFill/>
-        </p:spPr>
-        <p:txBody>
-          <a:bodyPr wrap="square">
-            <a:spAutoFit/>
-          </a:bodyPr>
-          <a:lstStyle/>
-          <a:p>
-            <a:pPr>
-              <a:spcAft>
-                <a:spcPts val="1200"/>
-              </a:spcAft>
-            </a:pPr>
-            <a:r>
-              <a:rPr sz="1800" b="0">
-                <a:solidFill>
-                  <a:srgbClr val="1A1A1A"/>
-                </a:solidFill>
-                <a:latin typeface="Calibri"/>
-              </a:rPr>
-              <a:t>1 Reel (or carousel) + 1 Story</a:t>
-            </a:r>
-          </a:p>
-          <a:p>
-            <a:pPr>
-              <a:spcAft>
-                <a:spcPts val="1200"/>
-              </a:spcAft>
-            </a:pPr>
-            <a:r>
-              <a:rPr sz="1800" b="0">
-                <a:solidFill>
-                  <a:srgbClr val="1A1A1A"/>
-                </a:solidFill>
-                <a:latin typeface="Calibri"/>
-              </a:rPr>
-              <a:t>Exclusive BarathX link (we provide)</a:t>
-            </a:r>
-          </a:p>
-          <a:p>
-            <a:pPr>
-              <a:spcAft>
-                <a:spcPts val="1200"/>
-              </a:spcAft>
-            </a:pPr>
-            <a:r>
-              <a:rPr sz="1800" b="0">
-                <a:solidFill>
-                  <a:srgbClr val="1A1A1A"/>
-                </a:solidFill>
-                <a:latin typeface="Calibri"/>
-              </a:rPr>
-              <a:t>CTA: create account → leave one take</a:t>
-            </a:r>
-          </a:p>
-          <a:p>
-            <a:pPr>
-              <a:spcAft>
-                <a:spcPts val="1200"/>
-              </a:spcAft>
-            </a:pPr>
-            <a:r>
-              <a:rPr sz="1800" b="0">
-                <a:solidFill>
-                  <a:srgbClr val="1A1A1A"/>
-                </a:solidFill>
-                <a:latin typeface="Calibri"/>
-              </a:rPr>
-              <a:t>Spelling: BarathX</a:t>
-            </a:r>
-          </a:p>
-        </p:txBody>
-      </p:sp>
-      <p:sp>
-        <p:nvSpPr>
-          <p:cNvPr id="4" name="TextBox 3"/>
-          <p:cNvSpPr txBox="1"/>
-          <p:nvPr/>
-        </p:nvSpPr>
-        <p:spPr>
-          <a:xfrm>
-            <a:off x="640080" y="6309360"/>
-            <a:ext cx="7863840" cy="320040"/>
-          </a:xfrm>
-          <a:prstGeom prst="rect">
-            <a:avLst/>
-          </a:prstGeom>
-          <a:noFill/>
-        </p:spPr>
-        <p:txBody>
-          <a:bodyPr wrap="none">
-            <a:spAutoFit/>
-          </a:bodyPr>
-          <a:lstStyle/>
-          <a:p>
-            <a:r>
-              <a:rPr sz="1200" b="0">
-                <a:solidFill>
-                  <a:srgbClr val="4A5563"/>
-                </a:solidFill>
-                <a:latin typeface="Calibri"/>
-              </a:rPr>
-              <a:t>barathx.com  ·  @getbarathx</a:t>
-            </a:r>
-          </a:p>
-        </p:txBody>
-      </p:sp>
+      </p:pic>
     </p:spTree>
   </p:cSld>
   <p:clrMapOvr>
@@ -3904,14 +3296,6 @@
 <file path=ppt/slides/slide6.xml><?xml version="1.0" encoding="utf-8"?>
 <p:sld xmlns:a="http://schemas.openxmlformats.org/drawingml/2006/main" xmlns:p="http://schemas.openxmlformats.org/presentationml/2006/main" xmlns:r="http://schemas.openxmlformats.org/officeDocument/2006/relationships">
   <p:cSld>
-    <p:bg>
-      <p:bgPr>
-        <a:solidFill>
-          <a:srgbClr val="F7F4EF"/>
-        </a:solidFill>
-        <a:effectLst/>
-      </p:bgPr>
-    </p:bg>
     <p:spTree>
       <p:nvGrpSpPr>
         <p:cNvPr id="1" name=""/>
@@ -3919,161 +3303,30 @@
         <p:nvPr/>
       </p:nvGrpSpPr>
       <p:grpSpPr/>
-      <p:sp>
-        <p:nvSpPr>
-          <p:cNvPr id="2" name="TextBox 1"/>
-          <p:cNvSpPr txBox="1"/>
+      <p:pic>
+        <p:nvPicPr>
+          <p:cNvPr id="2" name="Picture 1" descr="06-ask.png"/>
+          <p:cNvPicPr>
+            <a:picLocks noChangeAspect="1"/>
+          </p:cNvPicPr>
           <p:nvPr/>
-        </p:nvSpPr>
+        </p:nvPicPr>
+        <p:blipFill>
+          <a:blip r:embed="rId2"/>
+          <a:stretch>
+            <a:fillRect/>
+          </a:stretch>
+        </p:blipFill>
         <p:spPr>
           <a:xfrm>
-            <a:off x="640080" y="777240"/>
-            <a:ext cx="7863840" cy="1371600"/>
+            <a:off x="0" y="0"/>
+            <a:ext cx="12191695" cy="6858000"/>
           </a:xfrm>
           <a:prstGeom prst="rect">
             <a:avLst/>
           </a:prstGeom>
-          <a:noFill/>
         </p:spPr>
-        <p:txBody>
-          <a:bodyPr wrap="square">
-            <a:spAutoFit/>
-          </a:bodyPr>
-          <a:lstStyle/>
-          <a:p>
-            <a:r>
-              <a:rPr sz="3200" b="1">
-                <a:solidFill>
-                  <a:srgbClr val="0B1F3A"/>
-                </a:solidFill>
-                <a:latin typeface="Calibri"/>
-              </a:rPr>
-              <a:t>Next step</a:t>
-            </a:r>
-          </a:p>
-        </p:txBody>
-      </p:sp>
-      <p:sp>
-        <p:nvSpPr>
-          <p:cNvPr id="3" name="TextBox 2"/>
-          <p:cNvSpPr txBox="1"/>
-          <p:nvPr/>
-        </p:nvSpPr>
-        <p:spPr>
-          <a:xfrm>
-            <a:off x="640080" y="2194560"/>
-            <a:ext cx="7863840" cy="3657600"/>
-          </a:xfrm>
-          <a:prstGeom prst="rect">
-            <a:avLst/>
-          </a:prstGeom>
-          <a:noFill/>
-        </p:spPr>
-        <p:txBody>
-          <a:bodyPr wrap="square">
-            <a:spAutoFit/>
-          </a:bodyPr>
-          <a:lstStyle/>
-          <a:p>
-            <a:pPr>
-              <a:spcAft>
-                <a:spcPts val="1200"/>
-              </a:spcAft>
-            </a:pPr>
-            <a:r>
-              <a:rPr sz="1800" b="0">
-                <a:solidFill>
-                  <a:srgbClr val="1A1A1A"/>
-                </a:solidFill>
-                <a:latin typeface="Calibri"/>
-              </a:rPr>
-              <a:t>Reply with how partnerships work on your side.</a:t>
-            </a:r>
-          </a:p>
-          <a:p>
-            <a:pPr>
-              <a:spcAft>
-                <a:spcPts val="1200"/>
-              </a:spcAft>
-            </a:pPr>
-            <a:r>
-              <a:rPr sz="1800" b="0">
-                <a:solidFill>
-                  <a:srgbClr val="1A1A1A"/>
-                </a:solidFill>
-                <a:latin typeface="Calibri"/>
-              </a:rPr>
-              <a:t>We’ll share an exclusive link + short brief if it’s a fit.</a:t>
-            </a:r>
-          </a:p>
-          <a:p>
-            <a:pPr>
-              <a:spcAft>
-                <a:spcPts val="1200"/>
-              </a:spcAft>
-            </a:pPr>
-            <a:r>
-              <a:rPr sz="1800" b="0">
-                <a:solidFill>
-                  <a:srgbClr val="1A1A1A"/>
-                </a:solidFill>
-                <a:latin typeface="Calibri"/>
-              </a:rPr>
-              <a:t>barathx.com</a:t>
-            </a:r>
-          </a:p>
-          <a:p>
-            <a:pPr>
-              <a:spcAft>
-                <a:spcPts val="1200"/>
-              </a:spcAft>
-            </a:pPr>
-            <a:r>
-              <a:rPr sz="1800" b="0">
-                <a:solidFill>
-                  <a:srgbClr val="1A1A1A"/>
-                </a:solidFill>
-                <a:latin typeface="Calibri"/>
-              </a:rPr>
-              <a:t>@getbarathx</a:t>
-            </a:r>
-          </a:p>
-        </p:txBody>
-      </p:sp>
-      <p:sp>
-        <p:nvSpPr>
-          <p:cNvPr id="4" name="TextBox 3"/>
-          <p:cNvSpPr txBox="1"/>
-          <p:nvPr/>
-        </p:nvSpPr>
-        <p:spPr>
-          <a:xfrm>
-            <a:off x="640080" y="6309360"/>
-            <a:ext cx="7863840" cy="320040"/>
-          </a:xfrm>
-          <a:prstGeom prst="rect">
-            <a:avLst/>
-          </a:prstGeom>
-          <a:noFill/>
-        </p:spPr>
-        <p:txBody>
-          <a:bodyPr wrap="none">
-            <a:spAutoFit/>
-          </a:bodyPr>
-          <a:lstStyle/>
-          <a:p>
-            <a:r>
-              <a:rPr sz="1200" b="0">
-                <a:solidFill>
-                  <a:srgbClr val="4A5563"/>
-                </a:solidFill>
-                <a:latin typeface="Calibri"/>
-              </a:rPr>
-              <a:t>barathx.com  ·  @getbarathx</a:t>
-            </a:r>
-          </a:p>
-        </p:txBody>
-      </p:sp>
+      </p:pic>
     </p:spTree>
   </p:cSld>
   <p:clrMapOvr>

</xml_diff>

<commit_message>
Add Nikhil Kamath follow-up and India-first deck refresh
Follow-up email ties BarathX to his Indian social thesis; PPT/PDF
now highlight human-only, safety/DPDP, no ads feed, and built for India.

Co-authored-by: sharathtestits-code <sharathtestits-code@users.noreply.github.com>
</commit_message>
<xml_diff>
--- a/brand/gtm/outreach/emails-2026-08-18/BarathX-Creator-Collab-Brief.pptx
+++ b/brand/gtm/outreach/emails-2026-08-18/BarathX-Creator-Collab-Brief.pptx
@@ -11,6 +11,9 @@
     <p:sldId id="259" r:id="rId10"/>
     <p:sldId id="260" r:id="rId11"/>
     <p:sldId id="261" r:id="rId12"/>
+    <p:sldId id="262" r:id="rId13"/>
+    <p:sldId id="263" r:id="rId14"/>
+    <p:sldId id="264" r:id="rId15"/>
   </p:sldIdLst>
   <p:sldSz cx="12191695" cy="6858000" type="screen4x3"/>
   <p:notesSz cx="6858000" cy="9144000"/>
@@ -3263,7 +3266,7 @@
       <p:grpSpPr/>
       <p:pic>
         <p:nvPicPr>
-          <p:cNvPr id="2" name="Picture 1" descr="05-india.png"/>
+          <p:cNvPr id="2" name="Picture 1" descr="05-human.png"/>
           <p:cNvPicPr>
             <a:picLocks noChangeAspect="1"/>
           </p:cNvPicPr>
@@ -3305,7 +3308,133 @@
       <p:grpSpPr/>
       <p:pic>
         <p:nvPicPr>
-          <p:cNvPr id="2" name="Picture 1" descr="06-ask.png"/>
+          <p:cNvPr id="2" name="Picture 1" descr="06-safety.png"/>
+          <p:cNvPicPr>
+            <a:picLocks noChangeAspect="1"/>
+          </p:cNvPicPr>
+          <p:nvPr/>
+        </p:nvPicPr>
+        <p:blipFill>
+          <a:blip r:embed="rId2"/>
+          <a:stretch>
+            <a:fillRect/>
+          </a:stretch>
+        </p:blipFill>
+        <p:spPr>
+          <a:xfrm>
+            <a:off x="0" y="0"/>
+            <a:ext cx="12191695" cy="6858000"/>
+          </a:xfrm>
+          <a:prstGeom prst="rect">
+            <a:avLst/>
+          </a:prstGeom>
+        </p:spPr>
+      </p:pic>
+    </p:spTree>
+  </p:cSld>
+  <p:clrMapOvr>
+    <a:masterClrMapping/>
+  </p:clrMapOvr>
+</p:sld>
+</file>
+
+<file path=ppt/slides/slide7.xml><?xml version="1.0" encoding="utf-8"?>
+<p:sld xmlns:a="http://schemas.openxmlformats.org/drawingml/2006/main" xmlns:p="http://schemas.openxmlformats.org/presentationml/2006/main" xmlns:r="http://schemas.openxmlformats.org/officeDocument/2006/relationships">
+  <p:cSld>
+    <p:spTree>
+      <p:nvGrpSpPr>
+        <p:cNvPr id="1" name=""/>
+        <p:cNvGrpSpPr/>
+        <p:nvPr/>
+      </p:nvGrpSpPr>
+      <p:grpSpPr/>
+      <p:pic>
+        <p:nvPicPr>
+          <p:cNvPr id="2" name="Picture 1" descr="07-no-ads.png"/>
+          <p:cNvPicPr>
+            <a:picLocks noChangeAspect="1"/>
+          </p:cNvPicPr>
+          <p:nvPr/>
+        </p:nvPicPr>
+        <p:blipFill>
+          <a:blip r:embed="rId2"/>
+          <a:stretch>
+            <a:fillRect/>
+          </a:stretch>
+        </p:blipFill>
+        <p:spPr>
+          <a:xfrm>
+            <a:off x="0" y="0"/>
+            <a:ext cx="12191695" cy="6858000"/>
+          </a:xfrm>
+          <a:prstGeom prst="rect">
+            <a:avLst/>
+          </a:prstGeom>
+        </p:spPr>
+      </p:pic>
+    </p:spTree>
+  </p:cSld>
+  <p:clrMapOvr>
+    <a:masterClrMapping/>
+  </p:clrMapOvr>
+</p:sld>
+</file>
+
+<file path=ppt/slides/slide8.xml><?xml version="1.0" encoding="utf-8"?>
+<p:sld xmlns:a="http://schemas.openxmlformats.org/drawingml/2006/main" xmlns:p="http://schemas.openxmlformats.org/presentationml/2006/main" xmlns:r="http://schemas.openxmlformats.org/officeDocument/2006/relationships">
+  <p:cSld>
+    <p:spTree>
+      <p:nvGrpSpPr>
+        <p:cNvPr id="1" name=""/>
+        <p:cNvGrpSpPr/>
+        <p:nvPr/>
+      </p:nvGrpSpPr>
+      <p:grpSpPr/>
+      <p:pic>
+        <p:nvPicPr>
+          <p:cNvPr id="2" name="Picture 1" descr="08-india.png"/>
+          <p:cNvPicPr>
+            <a:picLocks noChangeAspect="1"/>
+          </p:cNvPicPr>
+          <p:nvPr/>
+        </p:nvPicPr>
+        <p:blipFill>
+          <a:blip r:embed="rId2"/>
+          <a:stretch>
+            <a:fillRect/>
+          </a:stretch>
+        </p:blipFill>
+        <p:spPr>
+          <a:xfrm>
+            <a:off x="0" y="0"/>
+            <a:ext cx="12191695" cy="6858000"/>
+          </a:xfrm>
+          <a:prstGeom prst="rect">
+            <a:avLst/>
+          </a:prstGeom>
+        </p:spPr>
+      </p:pic>
+    </p:spTree>
+  </p:cSld>
+  <p:clrMapOvr>
+    <a:masterClrMapping/>
+  </p:clrMapOvr>
+</p:sld>
+</file>
+
+<file path=ppt/slides/slide9.xml><?xml version="1.0" encoding="utf-8"?>
+<p:sld xmlns:a="http://schemas.openxmlformats.org/drawingml/2006/main" xmlns:p="http://schemas.openxmlformats.org/presentationml/2006/main" xmlns:r="http://schemas.openxmlformats.org/officeDocument/2006/relationships">
+  <p:cSld>
+    <p:spTree>
+      <p:nvGrpSpPr>
+        <p:cNvPr id="1" name=""/>
+        <p:cNvGrpSpPr/>
+        <p:nvPr/>
+      </p:nvGrpSpPr>
+      <p:grpSpPr/>
+      <p:pic>
+        <p:nvPicPr>
+          <p:cNvPr id="2" name="Picture 1" descr="09-ask.png"/>
           <p:cNvPicPr>
             <a:picLocks noChangeAspect="1"/>
           </p:cNvPicPr>

</xml_diff>